<commit_message>
Add sample Arab wedding invitation and show it in the deck
Arched ivory-and-gold invitation design (PNG + its HTML source),
used as the invitation image inside the guest phone mock.

Co-Authored-By: Claude Opus 5.5 <noreply@anthropic.com>
Claude-Session: https://claude.ai/code/session_01S2ZwXDDtsRDF4oseyuHCBz
</commit_message>
<xml_diff>
--- a/docs/presentation/daawatey-presentation-ar.pptx
+++ b/docs/presentation/daawatey-presentation-ar.pptx
@@ -17408,11 +17408,11 @@
             </a:avLst>
           </a:prstGeom>
           <a:solidFill>
-            <a:srgbClr val="E8C98A"/>
+            <a:srgbClr val="0B2228"/>
           </a:solidFill>
           <a:ln w="12700">
             <a:solidFill>
-              <a:srgbClr val="E8C98A"/>
+              <a:srgbClr val="0B2228"/>
             </a:solidFill>
             <a:prstDash val="solid"/>
           </a:ln>
@@ -17420,7 +17420,7 @@
       </p:sp>
       <p:pic>
         <p:nvPicPr>
-          <p:cNvPr id="7" name="Image 0" descr="preencoded.png">    </p:cNvPr>
+          <p:cNvPr id="7" name="Image 0" descr="wedding-invitation.png">    </p:cNvPr>
           <p:cNvPicPr>
             <a:picLocks noChangeAspect="1"/>
           </p:cNvPicPr>
@@ -17434,8 +17434,8 @@
         </p:blipFill>
         <p:spPr>
           <a:xfrm>
-            <a:off x="2011680" y="1947672"/>
-            <a:ext cx="457200" cy="457200"/>
+            <a:off x="1680667" y="1691640"/>
+            <a:ext cx="1119226" cy="1554480"/>
           </a:xfrm>
           <a:prstGeom prst="rect">
             <a:avLst/>
@@ -17445,45 +17445,6 @@
       <p:sp>
         <p:nvSpPr>
           <p:cNvPr id="8" name="Text 5"/>
-          <p:cNvSpPr txBox="1"/>
-          <p:nvPr/>
-        </p:nvSpPr>
-        <p:spPr>
-          <a:xfrm>
-            <a:off x="1051560" y="2542032"/>
-            <a:ext cx="2377440" cy="320040"/>
-          </a:xfrm>
-          <a:prstGeom prst="rect">
-            <a:avLst/>
-          </a:prstGeom>
-          <a:noFill/>
-          <a:ln/>
-        </p:spPr>
-        <p:txBody>
-          <a:bodyPr wrap="square" lIns="0" tIns="0" rIns="0" bIns="0" rtlCol="0" anchor="t"/>
-          <a:lstStyle/>
-          <a:p>
-            <a:pPr rtl="1" algn="ctr" indent="0" marL="0">
-              <a:buNone/>
-            </a:pPr>
-            <a:r>
-              <a:rPr lang="ar-SA" altLang="en-US" sz="1100" b="1" dirty="0">
-                <a:solidFill>
-                  <a:srgbClr val="171C26"/>
-                </a:solidFill>
-                <a:latin typeface="Arial" pitchFamily="34" charset="0"/>
-                <a:ea typeface="Arial" pitchFamily="34" charset="-122"/>
-                <a:cs typeface="Arial" pitchFamily="34" charset="-120"/>
-              </a:rPr>
-              <a:t>صورة الدعوة</a:t>
-            </a:r>
-            <a:endParaRPr lang="ar-SA" sz="1100" dirty="0"/>
-          </a:p>
-        </p:txBody>
-      </p:sp>
-      <p:sp>
-        <p:nvSpPr>
-          <p:cNvPr id="9" name="Text 6"/>
           <p:cNvSpPr txBox="1"/>
           <p:nvPr/>
         </p:nvSpPr>
@@ -17556,7 +17517,7 @@
       </p:sp>
       <p:sp>
         <p:nvSpPr>
-          <p:cNvPr id="10" name="Shape 7"/>
+          <p:cNvPr id="9" name="Shape 6"/>
           <p:cNvSpPr/>
           <p:nvPr/>
         </p:nvSpPr>
@@ -17583,7 +17544,7 @@
       </p:sp>
       <p:sp>
         <p:nvSpPr>
-          <p:cNvPr id="11" name="Text 8"/>
+          <p:cNvPr id="10" name="Text 7"/>
           <p:cNvSpPr txBox="1"/>
           <p:nvPr/>
         </p:nvSpPr>
@@ -17622,7 +17583,7 @@
       </p:sp>
       <p:sp>
         <p:nvSpPr>
-          <p:cNvPr id="12" name="Shape 9"/>
+          <p:cNvPr id="11" name="Shape 8"/>
           <p:cNvSpPr/>
           <p:nvPr/>
         </p:nvSpPr>
@@ -17649,7 +17610,7 @@
       </p:sp>
       <p:sp>
         <p:nvSpPr>
-          <p:cNvPr id="13" name="Text 10"/>
+          <p:cNvPr id="12" name="Text 9"/>
           <p:cNvSpPr txBox="1"/>
           <p:nvPr/>
         </p:nvSpPr>
@@ -17688,7 +17649,7 @@
       </p:sp>
       <p:sp>
         <p:nvSpPr>
-          <p:cNvPr id="14" name="Shape 11"/>
+          <p:cNvPr id="13" name="Shape 10"/>
           <p:cNvSpPr/>
           <p:nvPr/>
         </p:nvSpPr>
@@ -17715,7 +17676,7 @@
       </p:sp>
       <p:sp>
         <p:nvSpPr>
-          <p:cNvPr id="15" name="Text 12"/>
+          <p:cNvPr id="14" name="Text 11"/>
           <p:cNvSpPr txBox="1"/>
           <p:nvPr/>
         </p:nvSpPr>
@@ -17754,7 +17715,7 @@
       </p:sp>
       <p:sp>
         <p:nvSpPr>
-          <p:cNvPr id="16" name="Text 13"/>
+          <p:cNvPr id="15" name="Text 12"/>
           <p:cNvSpPr txBox="1"/>
           <p:nvPr/>
         </p:nvSpPr>
@@ -17793,7 +17754,7 @@
       </p:sp>
       <p:sp>
         <p:nvSpPr>
-          <p:cNvPr id="17" name="Shape 14"/>
+          <p:cNvPr id="16" name="Shape 13"/>
           <p:cNvSpPr/>
           <p:nvPr/>
         </p:nvSpPr>
@@ -17820,7 +17781,7 @@
       </p:sp>
       <p:sp>
         <p:nvSpPr>
-          <p:cNvPr id="18" name="Text 15"/>
+          <p:cNvPr id="17" name="Text 14"/>
           <p:cNvSpPr txBox="1"/>
           <p:nvPr/>
         </p:nvSpPr>
@@ -17859,7 +17820,7 @@
       </p:sp>
       <p:sp>
         <p:nvSpPr>
-          <p:cNvPr id="19" name="Shape 16"/>
+          <p:cNvPr id="18" name="Shape 15"/>
           <p:cNvSpPr/>
           <p:nvPr/>
         </p:nvSpPr>
@@ -17886,7 +17847,7 @@
       </p:sp>
       <p:sp>
         <p:nvSpPr>
-          <p:cNvPr id="20" name="Text 17"/>
+          <p:cNvPr id="19" name="Text 16"/>
           <p:cNvSpPr txBox="1"/>
           <p:nvPr/>
         </p:nvSpPr>
@@ -17925,7 +17886,7 @@
       </p:sp>
       <p:sp>
         <p:nvSpPr>
-          <p:cNvPr id="21" name="Shape 18"/>
+          <p:cNvPr id="20" name="Shape 17"/>
           <p:cNvSpPr/>
           <p:nvPr/>
         </p:nvSpPr>
@@ -17950,7 +17911,7 @@
       </p:sp>
       <p:pic>
         <p:nvPicPr>
-          <p:cNvPr id="22" name="Image 1" descr="preencoded.png">    </p:cNvPr>
+          <p:cNvPr id="21" name="Image 1" descr="preencoded.png">    </p:cNvPr>
           <p:cNvPicPr>
             <a:picLocks noChangeAspect="1"/>
           </p:cNvPicPr>
@@ -17974,7 +17935,7 @@
       </p:pic>
       <p:sp>
         <p:nvSpPr>
-          <p:cNvPr id="23" name="Text 19"/>
+          <p:cNvPr id="22" name="Text 18"/>
           <p:cNvSpPr txBox="1"/>
           <p:nvPr/>
         </p:nvSpPr>
@@ -18013,7 +17974,7 @@
       </p:sp>
       <p:sp>
         <p:nvSpPr>
-          <p:cNvPr id="24" name="Text 20"/>
+          <p:cNvPr id="23" name="Text 19"/>
           <p:cNvSpPr txBox="1"/>
           <p:nvPr/>
         </p:nvSpPr>
@@ -18052,7 +18013,7 @@
       </p:sp>
       <p:sp>
         <p:nvSpPr>
-          <p:cNvPr id="25" name="Shape 21"/>
+          <p:cNvPr id="24" name="Shape 20"/>
           <p:cNvSpPr/>
           <p:nvPr/>
         </p:nvSpPr>
@@ -18077,7 +18038,7 @@
       </p:sp>
       <p:pic>
         <p:nvPicPr>
-          <p:cNvPr id="26" name="Image 2" descr="preencoded.png">    </p:cNvPr>
+          <p:cNvPr id="25" name="Image 2" descr="preencoded.png">    </p:cNvPr>
           <p:cNvPicPr>
             <a:picLocks noChangeAspect="1"/>
           </p:cNvPicPr>
@@ -18101,7 +18062,7 @@
       </p:pic>
       <p:sp>
         <p:nvSpPr>
-          <p:cNvPr id="27" name="Text 22"/>
+          <p:cNvPr id="26" name="Text 21"/>
           <p:cNvSpPr txBox="1"/>
           <p:nvPr/>
         </p:nvSpPr>
@@ -18140,7 +18101,7 @@
       </p:sp>
       <p:sp>
         <p:nvSpPr>
-          <p:cNvPr id="28" name="Text 23"/>
+          <p:cNvPr id="27" name="Text 22"/>
           <p:cNvSpPr txBox="1"/>
           <p:nvPr/>
         </p:nvSpPr>
@@ -18179,7 +18140,7 @@
       </p:sp>
       <p:sp>
         <p:nvSpPr>
-          <p:cNvPr id="29" name="Shape 24"/>
+          <p:cNvPr id="28" name="Shape 23"/>
           <p:cNvSpPr/>
           <p:nvPr/>
         </p:nvSpPr>
@@ -18204,7 +18165,7 @@
       </p:sp>
       <p:pic>
         <p:nvPicPr>
-          <p:cNvPr id="30" name="Image 3" descr="preencoded.png">    </p:cNvPr>
+          <p:cNvPr id="29" name="Image 3" descr="preencoded.png">    </p:cNvPr>
           <p:cNvPicPr>
             <a:picLocks noChangeAspect="1"/>
           </p:cNvPicPr>
@@ -18228,7 +18189,7 @@
       </p:pic>
       <p:sp>
         <p:nvSpPr>
-          <p:cNvPr id="31" name="Text 25"/>
+          <p:cNvPr id="30" name="Text 24"/>
           <p:cNvSpPr txBox="1"/>
           <p:nvPr/>
         </p:nvSpPr>
@@ -18267,7 +18228,7 @@
       </p:sp>
       <p:sp>
         <p:nvSpPr>
-          <p:cNvPr id="32" name="Text 26"/>
+          <p:cNvPr id="31" name="Text 25"/>
           <p:cNvSpPr txBox="1"/>
           <p:nvPr/>
         </p:nvSpPr>
@@ -18306,7 +18267,7 @@
       </p:sp>
       <p:sp>
         <p:nvSpPr>
-          <p:cNvPr id="33" name="Shape 27"/>
+          <p:cNvPr id="32" name="Shape 26"/>
           <p:cNvSpPr/>
           <p:nvPr/>
         </p:nvSpPr>
@@ -18331,7 +18292,7 @@
       </p:sp>
       <p:pic>
         <p:nvPicPr>
-          <p:cNvPr id="34" name="Image 4" descr="preencoded.png">    </p:cNvPr>
+          <p:cNvPr id="33" name="Image 4" descr="preencoded.png">    </p:cNvPr>
           <p:cNvPicPr>
             <a:picLocks noChangeAspect="1"/>
           </p:cNvPicPr>
@@ -18355,7 +18316,7 @@
       </p:pic>
       <p:sp>
         <p:nvSpPr>
-          <p:cNvPr id="35" name="Text 28"/>
+          <p:cNvPr id="34" name="Text 27"/>
           <p:cNvSpPr txBox="1"/>
           <p:nvPr/>
         </p:nvSpPr>
@@ -18394,7 +18355,7 @@
       </p:sp>
       <p:sp>
         <p:nvSpPr>
-          <p:cNvPr id="36" name="Text 29"/>
+          <p:cNvPr id="35" name="Text 28"/>
           <p:cNvSpPr txBox="1"/>
           <p:nvPr/>
         </p:nvSpPr>

</xml_diff>